<commit_message>
fixing merge error on practice task
</commit_message>
<xml_diff>
--- a/stimuli/Instructions.pptx
+++ b/stimuli/Instructions.pptx
@@ -253,7 +253,7 @@
           <a:p>
             <a:fld id="{DD486318-9DF8-4AB8-B4FE-404675D97C09}" type="datetimeFigureOut">
               <a:rPr lang="en-US" smtClean="0"/>
-              <a:t>1/28/2022</a:t>
+              <a:t>2/8/2022</a:t>
             </a:fld>
             <a:endParaRPr lang="en-US"/>
           </a:p>
@@ -423,7 +423,7 @@
           <a:p>
             <a:fld id="{DD486318-9DF8-4AB8-B4FE-404675D97C09}" type="datetimeFigureOut">
               <a:rPr lang="en-US" smtClean="0"/>
-              <a:t>1/28/2022</a:t>
+              <a:t>2/8/2022</a:t>
             </a:fld>
             <a:endParaRPr lang="en-US"/>
           </a:p>
@@ -603,7 +603,7 @@
           <a:p>
             <a:fld id="{DD486318-9DF8-4AB8-B4FE-404675D97C09}" type="datetimeFigureOut">
               <a:rPr lang="en-US" smtClean="0"/>
-              <a:t>1/28/2022</a:t>
+              <a:t>2/8/2022</a:t>
             </a:fld>
             <a:endParaRPr lang="en-US"/>
           </a:p>
@@ -773,7 +773,7 @@
           <a:p>
             <a:fld id="{DD486318-9DF8-4AB8-B4FE-404675D97C09}" type="datetimeFigureOut">
               <a:rPr lang="en-US" smtClean="0"/>
-              <a:t>1/28/2022</a:t>
+              <a:t>2/8/2022</a:t>
             </a:fld>
             <a:endParaRPr lang="en-US"/>
           </a:p>
@@ -1019,7 +1019,7 @@
           <a:p>
             <a:fld id="{DD486318-9DF8-4AB8-B4FE-404675D97C09}" type="datetimeFigureOut">
               <a:rPr lang="en-US" smtClean="0"/>
-              <a:t>1/28/2022</a:t>
+              <a:t>2/8/2022</a:t>
             </a:fld>
             <a:endParaRPr lang="en-US"/>
           </a:p>
@@ -1251,7 +1251,7 @@
           <a:p>
             <a:fld id="{DD486318-9DF8-4AB8-B4FE-404675D97C09}" type="datetimeFigureOut">
               <a:rPr lang="en-US" smtClean="0"/>
-              <a:t>1/28/2022</a:t>
+              <a:t>2/8/2022</a:t>
             </a:fld>
             <a:endParaRPr lang="en-US"/>
           </a:p>
@@ -1618,7 +1618,7 @@
           <a:p>
             <a:fld id="{DD486318-9DF8-4AB8-B4FE-404675D97C09}" type="datetimeFigureOut">
               <a:rPr lang="en-US" smtClean="0"/>
-              <a:t>1/28/2022</a:t>
+              <a:t>2/8/2022</a:t>
             </a:fld>
             <a:endParaRPr lang="en-US"/>
           </a:p>
@@ -1736,7 +1736,7 @@
           <a:p>
             <a:fld id="{DD486318-9DF8-4AB8-B4FE-404675D97C09}" type="datetimeFigureOut">
               <a:rPr lang="en-US" smtClean="0"/>
-              <a:t>1/28/2022</a:t>
+              <a:t>2/8/2022</a:t>
             </a:fld>
             <a:endParaRPr lang="en-US"/>
           </a:p>
@@ -1831,7 +1831,7 @@
           <a:p>
             <a:fld id="{DD486318-9DF8-4AB8-B4FE-404675D97C09}" type="datetimeFigureOut">
               <a:rPr lang="en-US" smtClean="0"/>
-              <a:t>1/28/2022</a:t>
+              <a:t>2/8/2022</a:t>
             </a:fld>
             <a:endParaRPr lang="en-US"/>
           </a:p>
@@ -2108,7 +2108,7 @@
           <a:p>
             <a:fld id="{DD486318-9DF8-4AB8-B4FE-404675D97C09}" type="datetimeFigureOut">
               <a:rPr lang="en-US" smtClean="0"/>
-              <a:t>1/28/2022</a:t>
+              <a:t>2/8/2022</a:t>
             </a:fld>
             <a:endParaRPr lang="en-US"/>
           </a:p>
@@ -2365,7 +2365,7 @@
           <a:p>
             <a:fld id="{DD486318-9DF8-4AB8-B4FE-404675D97C09}" type="datetimeFigureOut">
               <a:rPr lang="en-US" smtClean="0"/>
-              <a:t>1/28/2022</a:t>
+              <a:t>2/8/2022</a:t>
             </a:fld>
             <a:endParaRPr lang="en-US"/>
           </a:p>
@@ -2578,7 +2578,7 @@
           <a:p>
             <a:fld id="{DD486318-9DF8-4AB8-B4FE-404675D97C09}" type="datetimeFigureOut">
               <a:rPr lang="en-US" smtClean="0"/>
-              <a:t>1/28/2022</a:t>
+              <a:t>2/8/2022</a:t>
             </a:fld>
             <a:endParaRPr lang="en-US"/>
           </a:p>
@@ -3343,8 +3343,8 @@
         </p:nvSpPr>
         <p:spPr bwMode="auto">
           <a:xfrm>
-            <a:off x="838199" y="1480864"/>
-            <a:ext cx="10515600" cy="4031873"/>
+            <a:off x="838199" y="1234643"/>
+            <a:ext cx="10515600" cy="4524315"/>
           </a:xfrm>
           <a:prstGeom prst="rect">
             <a:avLst/>
@@ -3471,7 +3471,39 @@
                 <a:effectLst/>
                 <a:latin typeface="Georgia" panose="02040502050405020303" pitchFamily="18" charset="0"/>
               </a:rPr>
-              <a:t>Today you’ll be doing an experimental task while we take pictures of your brain as you lay in the MRI machine.</a:t>
+              <a:t>Welcome to th</a:t>
+            </a:r>
+            <a:r>
+              <a:rPr lang="en-US" altLang="en-US" sz="3200" dirty="0" smtClean="0">
+                <a:latin typeface="Georgia" panose="02040502050405020303" pitchFamily="18" charset="0"/>
+              </a:rPr>
+              <a:t>e mock scanner. Here we are going to practice the task </a:t>
+            </a:r>
+            <a:r>
+              <a:rPr kumimoji="0" lang="en-US" altLang="en-US" sz="3200" b="0" i="0" u="none" strike="noStrike" cap="none" normalizeH="0" baseline="0" dirty="0" smtClean="0">
+                <a:ln>
+                  <a:noFill/>
+                </a:ln>
+                <a:solidFill>
+                  <a:schemeClr val="tx1"/>
+                </a:solidFill>
+                <a:effectLst/>
+                <a:latin typeface="Georgia" panose="02040502050405020303" pitchFamily="18" charset="0"/>
+              </a:rPr>
+              <a:t>that you will soon complete 6 repetitions of in the </a:t>
+            </a:r>
+            <a:r>
+              <a:rPr kumimoji="0" lang="en-US" altLang="en-US" sz="3200" b="0" i="0" u="none" strike="noStrike" cap="none" normalizeH="0" baseline="0" dirty="0" smtClean="0">
+                <a:ln>
+                  <a:noFill/>
+                </a:ln>
+                <a:solidFill>
+                  <a:schemeClr val="tx1"/>
+                </a:solidFill>
+                <a:effectLst/>
+                <a:latin typeface="Georgia" panose="02040502050405020303" pitchFamily="18" charset="0"/>
+              </a:rPr>
+              <a:t>MRI machine.</a:t>
             </a:r>
           </a:p>
           <a:p>
@@ -3512,7 +3544,13 @@
               <a:rPr lang="en-US" altLang="en-US" sz="3200" dirty="0" smtClean="0">
                 <a:latin typeface="Georgia" panose="02040502050405020303" pitchFamily="18" charset="0"/>
               </a:rPr>
-              <a:t>You’ll be playing a game called the</a:t>
+              <a:t>Today you’ll </a:t>
+            </a:r>
+            <a:r>
+              <a:rPr lang="en-US" altLang="en-US" sz="3200" dirty="0" smtClean="0">
+                <a:latin typeface="Georgia" panose="02040502050405020303" pitchFamily="18" charset="0"/>
+              </a:rPr>
+              <a:t>be playing a game called the</a:t>
             </a:r>
             <a:br>
               <a:rPr lang="en-US" altLang="en-US" sz="3200" dirty="0" smtClean="0">
@@ -3866,17 +3904,8 @@
               <a:rPr lang="en-US" altLang="en-US" dirty="0" smtClean="0">
                 <a:latin typeface="Georgia" panose="02040502050405020303" pitchFamily="18" charset="0"/>
               </a:rPr>
-              <a:t> the monetary outcomes of the task with </a:t>
-            </a:r>
-            <a:r>
-              <a:rPr lang="en-US" altLang="en-US" dirty="0" smtClean="0">
-                <a:latin typeface="Georgia" panose="02040502050405020303" pitchFamily="18" charset="0"/>
-              </a:rPr>
-              <a:t>them.</a:t>
-            </a:r>
-            <a:endParaRPr lang="en-US" altLang="en-US" dirty="0" smtClean="0">
-              <a:latin typeface="Georgia" panose="02040502050405020303" pitchFamily="18" charset="0"/>
-            </a:endParaRPr>
+              <a:t> the monetary outcomes of the task with them.</a:t>
+            </a:r>
           </a:p>
           <a:p>
             <a:pPr marL="0" lvl="0" indent="0" algn="ctr" eaLnBrk="0" fontAlgn="base" hangingPunct="0">
@@ -4267,13 +4296,7 @@
               <a:rPr lang="en-US" smtClean="0">
                 <a:latin typeface="Georgia" panose="02040502050405020303" pitchFamily="18" charset="0"/>
               </a:rPr>
-              <a:t>recent </a:t>
-            </a:r>
-            <a:r>
-              <a:rPr lang="en-US" smtClean="0">
-                <a:latin typeface="Georgia" panose="02040502050405020303" pitchFamily="18" charset="0"/>
-              </a:rPr>
-              <a:t>participant whose </a:t>
+              <a:t>recent participant whose </a:t>
             </a:r>
             <a:r>
               <a:rPr lang="en-US" dirty="0" smtClean="0">
@@ -4757,7 +4780,19 @@
               <a:rPr lang="en-US" dirty="0" smtClean="0">
                 <a:latin typeface="Georgia" panose="02040502050405020303" pitchFamily="18" charset="0"/>
               </a:rPr>
-              <a:t>If the card had been a ‘4,’ then a guess of ‘lower than 5’ would have been correct. In this case you would see a green arrow pointing up, meaning monetary gain of </a:t>
+              <a:t>If the card had been a ‘4,’ then a guess of ‘lower than 5’ would have been correct. In this case you would see a green arrow pointing up, </a:t>
+            </a:r>
+            <a:r>
+              <a:rPr lang="en-US" dirty="0" smtClean="0">
+                <a:latin typeface="Georgia" panose="02040502050405020303" pitchFamily="18" charset="0"/>
+              </a:rPr>
+              <a:t>meaning a </a:t>
+            </a:r>
+            <a:r>
+              <a:rPr lang="en-US" dirty="0" smtClean="0">
+                <a:latin typeface="Georgia" panose="02040502050405020303" pitchFamily="18" charset="0"/>
+              </a:rPr>
+              <a:t>monetary gain of </a:t>
             </a:r>
             <a:r>
               <a:rPr lang="en-US" dirty="0">
@@ -4775,7 +4810,13 @@
               <a:rPr lang="en-US" dirty="0" smtClean="0">
                 <a:latin typeface="Georgia" panose="02040502050405020303" pitchFamily="18" charset="0"/>
               </a:rPr>
-              <a:t>each for you the partner on the screen</a:t>
+              <a:t>each for both you and the </a:t>
+            </a:r>
+            <a:r>
+              <a:rPr lang="en-US" dirty="0" smtClean="0">
+                <a:latin typeface="Georgia" panose="02040502050405020303" pitchFamily="18" charset="0"/>
+              </a:rPr>
+              <a:t>partner on the screen</a:t>
             </a:r>
             <a:endParaRPr lang="en-US" dirty="0">
               <a:latin typeface="Georgia" panose="02040502050405020303" pitchFamily="18" charset="0"/>

</xml_diff>

<commit_message>
adding shared reward practice and Instructions to the repo
</commit_message>
<xml_diff>
--- a/stimuli/Instructions.pptx
+++ b/stimuli/Instructions.pptx
@@ -253,7 +253,7 @@
           <a:p>
             <a:fld id="{DD486318-9DF8-4AB8-B4FE-404675D97C09}" type="datetimeFigureOut">
               <a:rPr lang="en-US" smtClean="0"/>
-              <a:t>1/28/2022</a:t>
+              <a:t>2/8/2022</a:t>
             </a:fld>
             <a:endParaRPr lang="en-US"/>
           </a:p>
@@ -423,7 +423,7 @@
           <a:p>
             <a:fld id="{DD486318-9DF8-4AB8-B4FE-404675D97C09}" type="datetimeFigureOut">
               <a:rPr lang="en-US" smtClean="0"/>
-              <a:t>1/28/2022</a:t>
+              <a:t>2/8/2022</a:t>
             </a:fld>
             <a:endParaRPr lang="en-US"/>
           </a:p>
@@ -603,7 +603,7 @@
           <a:p>
             <a:fld id="{DD486318-9DF8-4AB8-B4FE-404675D97C09}" type="datetimeFigureOut">
               <a:rPr lang="en-US" smtClean="0"/>
-              <a:t>1/28/2022</a:t>
+              <a:t>2/8/2022</a:t>
             </a:fld>
             <a:endParaRPr lang="en-US"/>
           </a:p>
@@ -773,7 +773,7 @@
           <a:p>
             <a:fld id="{DD486318-9DF8-4AB8-B4FE-404675D97C09}" type="datetimeFigureOut">
               <a:rPr lang="en-US" smtClean="0"/>
-              <a:t>1/28/2022</a:t>
+              <a:t>2/8/2022</a:t>
             </a:fld>
             <a:endParaRPr lang="en-US"/>
           </a:p>
@@ -1019,7 +1019,7 @@
           <a:p>
             <a:fld id="{DD486318-9DF8-4AB8-B4FE-404675D97C09}" type="datetimeFigureOut">
               <a:rPr lang="en-US" smtClean="0"/>
-              <a:t>1/28/2022</a:t>
+              <a:t>2/8/2022</a:t>
             </a:fld>
             <a:endParaRPr lang="en-US"/>
           </a:p>
@@ -1251,7 +1251,7 @@
           <a:p>
             <a:fld id="{DD486318-9DF8-4AB8-B4FE-404675D97C09}" type="datetimeFigureOut">
               <a:rPr lang="en-US" smtClean="0"/>
-              <a:t>1/28/2022</a:t>
+              <a:t>2/8/2022</a:t>
             </a:fld>
             <a:endParaRPr lang="en-US"/>
           </a:p>
@@ -1618,7 +1618,7 @@
           <a:p>
             <a:fld id="{DD486318-9DF8-4AB8-B4FE-404675D97C09}" type="datetimeFigureOut">
               <a:rPr lang="en-US" smtClean="0"/>
-              <a:t>1/28/2022</a:t>
+              <a:t>2/8/2022</a:t>
             </a:fld>
             <a:endParaRPr lang="en-US"/>
           </a:p>
@@ -1736,7 +1736,7 @@
           <a:p>
             <a:fld id="{DD486318-9DF8-4AB8-B4FE-404675D97C09}" type="datetimeFigureOut">
               <a:rPr lang="en-US" smtClean="0"/>
-              <a:t>1/28/2022</a:t>
+              <a:t>2/8/2022</a:t>
             </a:fld>
             <a:endParaRPr lang="en-US"/>
           </a:p>
@@ -1831,7 +1831,7 @@
           <a:p>
             <a:fld id="{DD486318-9DF8-4AB8-B4FE-404675D97C09}" type="datetimeFigureOut">
               <a:rPr lang="en-US" smtClean="0"/>
-              <a:t>1/28/2022</a:t>
+              <a:t>2/8/2022</a:t>
             </a:fld>
             <a:endParaRPr lang="en-US"/>
           </a:p>
@@ -2108,7 +2108,7 @@
           <a:p>
             <a:fld id="{DD486318-9DF8-4AB8-B4FE-404675D97C09}" type="datetimeFigureOut">
               <a:rPr lang="en-US" smtClean="0"/>
-              <a:t>1/28/2022</a:t>
+              <a:t>2/8/2022</a:t>
             </a:fld>
             <a:endParaRPr lang="en-US"/>
           </a:p>
@@ -2365,7 +2365,7 @@
           <a:p>
             <a:fld id="{DD486318-9DF8-4AB8-B4FE-404675D97C09}" type="datetimeFigureOut">
               <a:rPr lang="en-US" smtClean="0"/>
-              <a:t>1/28/2022</a:t>
+              <a:t>2/8/2022</a:t>
             </a:fld>
             <a:endParaRPr lang="en-US"/>
           </a:p>
@@ -2578,7 +2578,7 @@
           <a:p>
             <a:fld id="{DD486318-9DF8-4AB8-B4FE-404675D97C09}" type="datetimeFigureOut">
               <a:rPr lang="en-US" smtClean="0"/>
-              <a:t>1/28/2022</a:t>
+              <a:t>2/8/2022</a:t>
             </a:fld>
             <a:endParaRPr lang="en-US"/>
           </a:p>
@@ -3343,8 +3343,8 @@
         </p:nvSpPr>
         <p:spPr bwMode="auto">
           <a:xfrm>
-            <a:off x="838199" y="1480864"/>
-            <a:ext cx="10515600" cy="4031873"/>
+            <a:off x="838199" y="1234643"/>
+            <a:ext cx="10515600" cy="4524315"/>
           </a:xfrm>
           <a:prstGeom prst="rect">
             <a:avLst/>
@@ -3471,7 +3471,39 @@
                 <a:effectLst/>
                 <a:latin typeface="Georgia" panose="02040502050405020303" pitchFamily="18" charset="0"/>
               </a:rPr>
-              <a:t>Today you’ll be doing an experimental task while we take pictures of your brain as you lay in the MRI machine.</a:t>
+              <a:t>Welcome to th</a:t>
+            </a:r>
+            <a:r>
+              <a:rPr lang="en-US" altLang="en-US" sz="3200" dirty="0" smtClean="0">
+                <a:latin typeface="Georgia" panose="02040502050405020303" pitchFamily="18" charset="0"/>
+              </a:rPr>
+              <a:t>e mock scanner. Here we are going to practice the task </a:t>
+            </a:r>
+            <a:r>
+              <a:rPr kumimoji="0" lang="en-US" altLang="en-US" sz="3200" b="0" i="0" u="none" strike="noStrike" cap="none" normalizeH="0" baseline="0" dirty="0" smtClean="0">
+                <a:ln>
+                  <a:noFill/>
+                </a:ln>
+                <a:solidFill>
+                  <a:schemeClr val="tx1"/>
+                </a:solidFill>
+                <a:effectLst/>
+                <a:latin typeface="Georgia" panose="02040502050405020303" pitchFamily="18" charset="0"/>
+              </a:rPr>
+              <a:t>that you will soon complete 6 repetitions of in the </a:t>
+            </a:r>
+            <a:r>
+              <a:rPr kumimoji="0" lang="en-US" altLang="en-US" sz="3200" b="0" i="0" u="none" strike="noStrike" cap="none" normalizeH="0" baseline="0" dirty="0" smtClean="0">
+                <a:ln>
+                  <a:noFill/>
+                </a:ln>
+                <a:solidFill>
+                  <a:schemeClr val="tx1"/>
+                </a:solidFill>
+                <a:effectLst/>
+                <a:latin typeface="Georgia" panose="02040502050405020303" pitchFamily="18" charset="0"/>
+              </a:rPr>
+              <a:t>MRI machine.</a:t>
             </a:r>
           </a:p>
           <a:p>
@@ -3512,7 +3544,13 @@
               <a:rPr lang="en-US" altLang="en-US" sz="3200" dirty="0" smtClean="0">
                 <a:latin typeface="Georgia" panose="02040502050405020303" pitchFamily="18" charset="0"/>
               </a:rPr>
-              <a:t>You’ll be playing a game called the</a:t>
+              <a:t>Today you’ll </a:t>
+            </a:r>
+            <a:r>
+              <a:rPr lang="en-US" altLang="en-US" sz="3200" dirty="0" smtClean="0">
+                <a:latin typeface="Georgia" panose="02040502050405020303" pitchFamily="18" charset="0"/>
+              </a:rPr>
+              <a:t>be playing a game called the</a:t>
             </a:r>
             <a:br>
               <a:rPr lang="en-US" altLang="en-US" sz="3200" dirty="0" smtClean="0">
@@ -3866,17 +3904,8 @@
               <a:rPr lang="en-US" altLang="en-US" dirty="0" smtClean="0">
                 <a:latin typeface="Georgia" panose="02040502050405020303" pitchFamily="18" charset="0"/>
               </a:rPr>
-              <a:t> the monetary outcomes of the task with </a:t>
-            </a:r>
-            <a:r>
-              <a:rPr lang="en-US" altLang="en-US" dirty="0" smtClean="0">
-                <a:latin typeface="Georgia" panose="02040502050405020303" pitchFamily="18" charset="0"/>
-              </a:rPr>
-              <a:t>them.</a:t>
-            </a:r>
-            <a:endParaRPr lang="en-US" altLang="en-US" dirty="0" smtClean="0">
-              <a:latin typeface="Georgia" panose="02040502050405020303" pitchFamily="18" charset="0"/>
-            </a:endParaRPr>
+              <a:t> the monetary outcomes of the task with them.</a:t>
+            </a:r>
           </a:p>
           <a:p>
             <a:pPr marL="0" lvl="0" indent="0" algn="ctr" eaLnBrk="0" fontAlgn="base" hangingPunct="0">
@@ -4267,13 +4296,7 @@
               <a:rPr lang="en-US" smtClean="0">
                 <a:latin typeface="Georgia" panose="02040502050405020303" pitchFamily="18" charset="0"/>
               </a:rPr>
-              <a:t>recent </a:t>
-            </a:r>
-            <a:r>
-              <a:rPr lang="en-US" smtClean="0">
-                <a:latin typeface="Georgia" panose="02040502050405020303" pitchFamily="18" charset="0"/>
-              </a:rPr>
-              <a:t>participant whose </a:t>
+              <a:t>recent participant whose </a:t>
             </a:r>
             <a:r>
               <a:rPr lang="en-US" dirty="0" smtClean="0">
@@ -4757,7 +4780,19 @@
               <a:rPr lang="en-US" dirty="0" smtClean="0">
                 <a:latin typeface="Georgia" panose="02040502050405020303" pitchFamily="18" charset="0"/>
               </a:rPr>
-              <a:t>If the card had been a ‘4,’ then a guess of ‘lower than 5’ would have been correct. In this case you would see a green arrow pointing up, meaning monetary gain of </a:t>
+              <a:t>If the card had been a ‘4,’ then a guess of ‘lower than 5’ would have been correct. In this case you would see a green arrow pointing up, </a:t>
+            </a:r>
+            <a:r>
+              <a:rPr lang="en-US" dirty="0" smtClean="0">
+                <a:latin typeface="Georgia" panose="02040502050405020303" pitchFamily="18" charset="0"/>
+              </a:rPr>
+              <a:t>meaning a </a:t>
+            </a:r>
+            <a:r>
+              <a:rPr lang="en-US" dirty="0" smtClean="0">
+                <a:latin typeface="Georgia" panose="02040502050405020303" pitchFamily="18" charset="0"/>
+              </a:rPr>
+              <a:t>monetary gain of </a:t>
             </a:r>
             <a:r>
               <a:rPr lang="en-US" dirty="0">
@@ -4775,7 +4810,13 @@
               <a:rPr lang="en-US" dirty="0" smtClean="0">
                 <a:latin typeface="Georgia" panose="02040502050405020303" pitchFamily="18" charset="0"/>
               </a:rPr>
-              <a:t>each for you the partner on the screen</a:t>
+              <a:t>each for both you and the </a:t>
+            </a:r>
+            <a:r>
+              <a:rPr lang="en-US" dirty="0" smtClean="0">
+                <a:latin typeface="Georgia" panose="02040502050405020303" pitchFamily="18" charset="0"/>
+              </a:rPr>
+              <a:t>partner on the screen</a:t>
             </a:r>
             <a:endParaRPr lang="en-US" dirty="0">
               <a:latin typeface="Georgia" panose="02040502050405020303" pitchFamily="18" charset="0"/>

</xml_diff>

<commit_message>
Revert "fixing merge error on practice task"
This reverts commit 07eaec158bfa6ebe264c3ebc00f8a9a563e1e2f3.
</commit_message>
<xml_diff>
--- a/stimuli/Instructions.pptx
+++ b/stimuli/Instructions.pptx
@@ -253,7 +253,7 @@
           <a:p>
             <a:fld id="{DD486318-9DF8-4AB8-B4FE-404675D97C09}" type="datetimeFigureOut">
               <a:rPr lang="en-US" smtClean="0"/>
-              <a:t>2/8/2022</a:t>
+              <a:t>1/28/2022</a:t>
             </a:fld>
             <a:endParaRPr lang="en-US"/>
           </a:p>
@@ -423,7 +423,7 @@
           <a:p>
             <a:fld id="{DD486318-9DF8-4AB8-B4FE-404675D97C09}" type="datetimeFigureOut">
               <a:rPr lang="en-US" smtClean="0"/>
-              <a:t>2/8/2022</a:t>
+              <a:t>1/28/2022</a:t>
             </a:fld>
             <a:endParaRPr lang="en-US"/>
           </a:p>
@@ -603,7 +603,7 @@
           <a:p>
             <a:fld id="{DD486318-9DF8-4AB8-B4FE-404675D97C09}" type="datetimeFigureOut">
               <a:rPr lang="en-US" smtClean="0"/>
-              <a:t>2/8/2022</a:t>
+              <a:t>1/28/2022</a:t>
             </a:fld>
             <a:endParaRPr lang="en-US"/>
           </a:p>
@@ -773,7 +773,7 @@
           <a:p>
             <a:fld id="{DD486318-9DF8-4AB8-B4FE-404675D97C09}" type="datetimeFigureOut">
               <a:rPr lang="en-US" smtClean="0"/>
-              <a:t>2/8/2022</a:t>
+              <a:t>1/28/2022</a:t>
             </a:fld>
             <a:endParaRPr lang="en-US"/>
           </a:p>
@@ -1019,7 +1019,7 @@
           <a:p>
             <a:fld id="{DD486318-9DF8-4AB8-B4FE-404675D97C09}" type="datetimeFigureOut">
               <a:rPr lang="en-US" smtClean="0"/>
-              <a:t>2/8/2022</a:t>
+              <a:t>1/28/2022</a:t>
             </a:fld>
             <a:endParaRPr lang="en-US"/>
           </a:p>
@@ -1251,7 +1251,7 @@
           <a:p>
             <a:fld id="{DD486318-9DF8-4AB8-B4FE-404675D97C09}" type="datetimeFigureOut">
               <a:rPr lang="en-US" smtClean="0"/>
-              <a:t>2/8/2022</a:t>
+              <a:t>1/28/2022</a:t>
             </a:fld>
             <a:endParaRPr lang="en-US"/>
           </a:p>
@@ -1618,7 +1618,7 @@
           <a:p>
             <a:fld id="{DD486318-9DF8-4AB8-B4FE-404675D97C09}" type="datetimeFigureOut">
               <a:rPr lang="en-US" smtClean="0"/>
-              <a:t>2/8/2022</a:t>
+              <a:t>1/28/2022</a:t>
             </a:fld>
             <a:endParaRPr lang="en-US"/>
           </a:p>
@@ -1736,7 +1736,7 @@
           <a:p>
             <a:fld id="{DD486318-9DF8-4AB8-B4FE-404675D97C09}" type="datetimeFigureOut">
               <a:rPr lang="en-US" smtClean="0"/>
-              <a:t>2/8/2022</a:t>
+              <a:t>1/28/2022</a:t>
             </a:fld>
             <a:endParaRPr lang="en-US"/>
           </a:p>
@@ -1831,7 +1831,7 @@
           <a:p>
             <a:fld id="{DD486318-9DF8-4AB8-B4FE-404675D97C09}" type="datetimeFigureOut">
               <a:rPr lang="en-US" smtClean="0"/>
-              <a:t>2/8/2022</a:t>
+              <a:t>1/28/2022</a:t>
             </a:fld>
             <a:endParaRPr lang="en-US"/>
           </a:p>
@@ -2108,7 +2108,7 @@
           <a:p>
             <a:fld id="{DD486318-9DF8-4AB8-B4FE-404675D97C09}" type="datetimeFigureOut">
               <a:rPr lang="en-US" smtClean="0"/>
-              <a:t>2/8/2022</a:t>
+              <a:t>1/28/2022</a:t>
             </a:fld>
             <a:endParaRPr lang="en-US"/>
           </a:p>
@@ -2365,7 +2365,7 @@
           <a:p>
             <a:fld id="{DD486318-9DF8-4AB8-B4FE-404675D97C09}" type="datetimeFigureOut">
               <a:rPr lang="en-US" smtClean="0"/>
-              <a:t>2/8/2022</a:t>
+              <a:t>1/28/2022</a:t>
             </a:fld>
             <a:endParaRPr lang="en-US"/>
           </a:p>
@@ -2578,7 +2578,7 @@
           <a:p>
             <a:fld id="{DD486318-9DF8-4AB8-B4FE-404675D97C09}" type="datetimeFigureOut">
               <a:rPr lang="en-US" smtClean="0"/>
-              <a:t>2/8/2022</a:t>
+              <a:t>1/28/2022</a:t>
             </a:fld>
             <a:endParaRPr lang="en-US"/>
           </a:p>
@@ -3343,8 +3343,8 @@
         </p:nvSpPr>
         <p:spPr bwMode="auto">
           <a:xfrm>
-            <a:off x="838199" y="1234643"/>
-            <a:ext cx="10515600" cy="4524315"/>
+            <a:off x="838199" y="1480864"/>
+            <a:ext cx="10515600" cy="4031873"/>
           </a:xfrm>
           <a:prstGeom prst="rect">
             <a:avLst/>
@@ -3471,39 +3471,7 @@
                 <a:effectLst/>
                 <a:latin typeface="Georgia" panose="02040502050405020303" pitchFamily="18" charset="0"/>
               </a:rPr>
-              <a:t>Welcome to th</a:t>
-            </a:r>
-            <a:r>
-              <a:rPr lang="en-US" altLang="en-US" sz="3200" dirty="0" smtClean="0">
-                <a:latin typeface="Georgia" panose="02040502050405020303" pitchFamily="18" charset="0"/>
-              </a:rPr>
-              <a:t>e mock scanner. Here we are going to practice the task </a:t>
-            </a:r>
-            <a:r>
-              <a:rPr kumimoji="0" lang="en-US" altLang="en-US" sz="3200" b="0" i="0" u="none" strike="noStrike" cap="none" normalizeH="0" baseline="0" dirty="0" smtClean="0">
-                <a:ln>
-                  <a:noFill/>
-                </a:ln>
-                <a:solidFill>
-                  <a:schemeClr val="tx1"/>
-                </a:solidFill>
-                <a:effectLst/>
-                <a:latin typeface="Georgia" panose="02040502050405020303" pitchFamily="18" charset="0"/>
-              </a:rPr>
-              <a:t>that you will soon complete 6 repetitions of in the </a:t>
-            </a:r>
-            <a:r>
-              <a:rPr kumimoji="0" lang="en-US" altLang="en-US" sz="3200" b="0" i="0" u="none" strike="noStrike" cap="none" normalizeH="0" baseline="0" dirty="0" smtClean="0">
-                <a:ln>
-                  <a:noFill/>
-                </a:ln>
-                <a:solidFill>
-                  <a:schemeClr val="tx1"/>
-                </a:solidFill>
-                <a:effectLst/>
-                <a:latin typeface="Georgia" panose="02040502050405020303" pitchFamily="18" charset="0"/>
-              </a:rPr>
-              <a:t>MRI machine.</a:t>
+              <a:t>Today you’ll be doing an experimental task while we take pictures of your brain as you lay in the MRI machine.</a:t>
             </a:r>
           </a:p>
           <a:p>
@@ -3544,13 +3512,7 @@
               <a:rPr lang="en-US" altLang="en-US" sz="3200" dirty="0" smtClean="0">
                 <a:latin typeface="Georgia" panose="02040502050405020303" pitchFamily="18" charset="0"/>
               </a:rPr>
-              <a:t>Today you’ll </a:t>
-            </a:r>
-            <a:r>
-              <a:rPr lang="en-US" altLang="en-US" sz="3200" dirty="0" smtClean="0">
-                <a:latin typeface="Georgia" panose="02040502050405020303" pitchFamily="18" charset="0"/>
-              </a:rPr>
-              <a:t>be playing a game called the</a:t>
+              <a:t>You’ll be playing a game called the</a:t>
             </a:r>
             <a:br>
               <a:rPr lang="en-US" altLang="en-US" sz="3200" dirty="0" smtClean="0">
@@ -3904,8 +3866,17 @@
               <a:rPr lang="en-US" altLang="en-US" dirty="0" smtClean="0">
                 <a:latin typeface="Georgia" panose="02040502050405020303" pitchFamily="18" charset="0"/>
               </a:rPr>
-              <a:t> the monetary outcomes of the task with them.</a:t>
-            </a:r>
+              <a:t> the monetary outcomes of the task with </a:t>
+            </a:r>
+            <a:r>
+              <a:rPr lang="en-US" altLang="en-US" dirty="0" smtClean="0">
+                <a:latin typeface="Georgia" panose="02040502050405020303" pitchFamily="18" charset="0"/>
+              </a:rPr>
+              <a:t>them.</a:t>
+            </a:r>
+            <a:endParaRPr lang="en-US" altLang="en-US" dirty="0" smtClean="0">
+              <a:latin typeface="Georgia" panose="02040502050405020303" pitchFamily="18" charset="0"/>
+            </a:endParaRPr>
           </a:p>
           <a:p>
             <a:pPr marL="0" lvl="0" indent="0" algn="ctr" eaLnBrk="0" fontAlgn="base" hangingPunct="0">
@@ -4296,7 +4267,13 @@
               <a:rPr lang="en-US" smtClean="0">
                 <a:latin typeface="Georgia" panose="02040502050405020303" pitchFamily="18" charset="0"/>
               </a:rPr>
-              <a:t>recent participant whose </a:t>
+              <a:t>recent </a:t>
+            </a:r>
+            <a:r>
+              <a:rPr lang="en-US" smtClean="0">
+                <a:latin typeface="Georgia" panose="02040502050405020303" pitchFamily="18" charset="0"/>
+              </a:rPr>
+              <a:t>participant whose </a:t>
             </a:r>
             <a:r>
               <a:rPr lang="en-US" dirty="0" smtClean="0">
@@ -4780,43 +4757,25 @@
               <a:rPr lang="en-US" dirty="0" smtClean="0">
                 <a:latin typeface="Georgia" panose="02040502050405020303" pitchFamily="18" charset="0"/>
               </a:rPr>
-              <a:t>If the card had been a ‘4,’ then a guess of ‘lower than 5’ would have been correct. In this case you would see a green arrow pointing up, </a:t>
+              <a:t>If the card had been a ‘4,’ then a guess of ‘lower than 5’ would have been correct. In this case you would see a green arrow pointing up, meaning monetary gain of </a:t>
+            </a:r>
+            <a:r>
+              <a:rPr lang="en-US" dirty="0">
+                <a:latin typeface="Georgia" panose="02040502050405020303" pitchFamily="18" charset="0"/>
+              </a:rPr>
+              <a:t>$</a:t>
             </a:r>
             <a:r>
               <a:rPr lang="en-US" dirty="0" smtClean="0">
                 <a:latin typeface="Georgia" panose="02040502050405020303" pitchFamily="18" charset="0"/>
               </a:rPr>
-              <a:t>meaning a </a:t>
+              <a:t>5 </a:t>
             </a:r>
             <a:r>
               <a:rPr lang="en-US" dirty="0" smtClean="0">
                 <a:latin typeface="Georgia" panose="02040502050405020303" pitchFamily="18" charset="0"/>
               </a:rPr>
-              <a:t>monetary gain of </a:t>
-            </a:r>
-            <a:r>
-              <a:rPr lang="en-US" dirty="0">
-                <a:latin typeface="Georgia" panose="02040502050405020303" pitchFamily="18" charset="0"/>
-              </a:rPr>
-              <a:t>$</a:t>
-            </a:r>
-            <a:r>
-              <a:rPr lang="en-US" dirty="0" smtClean="0">
-                <a:latin typeface="Georgia" panose="02040502050405020303" pitchFamily="18" charset="0"/>
-              </a:rPr>
-              <a:t>5 </a:t>
-            </a:r>
-            <a:r>
-              <a:rPr lang="en-US" dirty="0" smtClean="0">
-                <a:latin typeface="Georgia" panose="02040502050405020303" pitchFamily="18" charset="0"/>
-              </a:rPr>
-              <a:t>each for both you and the </a:t>
-            </a:r>
-            <a:r>
-              <a:rPr lang="en-US" dirty="0" smtClean="0">
-                <a:latin typeface="Georgia" panose="02040502050405020303" pitchFamily="18" charset="0"/>
-              </a:rPr>
-              <a:t>partner on the screen</a:t>
+              <a:t>each for you the partner on the screen</a:t>
             </a:r>
             <a:endParaRPr lang="en-US" dirty="0">
               <a:latin typeface="Georgia" panose="02040502050405020303" pitchFamily="18" charset="0"/>

</xml_diff>

<commit_message>
re-push of working practice task
</commit_message>
<xml_diff>
--- a/stimuli/Instructions.pptx
+++ b/stimuli/Instructions.pptx
@@ -253,7 +253,7 @@
           <a:p>
             <a:fld id="{DD486318-9DF8-4AB8-B4FE-404675D97C09}" type="datetimeFigureOut">
               <a:rPr lang="en-US" smtClean="0"/>
-              <a:t>1/28/2022</a:t>
+              <a:t>2/8/2022</a:t>
             </a:fld>
             <a:endParaRPr lang="en-US"/>
           </a:p>
@@ -423,7 +423,7 @@
           <a:p>
             <a:fld id="{DD486318-9DF8-4AB8-B4FE-404675D97C09}" type="datetimeFigureOut">
               <a:rPr lang="en-US" smtClean="0"/>
-              <a:t>1/28/2022</a:t>
+              <a:t>2/8/2022</a:t>
             </a:fld>
             <a:endParaRPr lang="en-US"/>
           </a:p>
@@ -603,7 +603,7 @@
           <a:p>
             <a:fld id="{DD486318-9DF8-4AB8-B4FE-404675D97C09}" type="datetimeFigureOut">
               <a:rPr lang="en-US" smtClean="0"/>
-              <a:t>1/28/2022</a:t>
+              <a:t>2/8/2022</a:t>
             </a:fld>
             <a:endParaRPr lang="en-US"/>
           </a:p>
@@ -773,7 +773,7 @@
           <a:p>
             <a:fld id="{DD486318-9DF8-4AB8-B4FE-404675D97C09}" type="datetimeFigureOut">
               <a:rPr lang="en-US" smtClean="0"/>
-              <a:t>1/28/2022</a:t>
+              <a:t>2/8/2022</a:t>
             </a:fld>
             <a:endParaRPr lang="en-US"/>
           </a:p>
@@ -1019,7 +1019,7 @@
           <a:p>
             <a:fld id="{DD486318-9DF8-4AB8-B4FE-404675D97C09}" type="datetimeFigureOut">
               <a:rPr lang="en-US" smtClean="0"/>
-              <a:t>1/28/2022</a:t>
+              <a:t>2/8/2022</a:t>
             </a:fld>
             <a:endParaRPr lang="en-US"/>
           </a:p>
@@ -1251,7 +1251,7 @@
           <a:p>
             <a:fld id="{DD486318-9DF8-4AB8-B4FE-404675D97C09}" type="datetimeFigureOut">
               <a:rPr lang="en-US" smtClean="0"/>
-              <a:t>1/28/2022</a:t>
+              <a:t>2/8/2022</a:t>
             </a:fld>
             <a:endParaRPr lang="en-US"/>
           </a:p>
@@ -1618,7 +1618,7 @@
           <a:p>
             <a:fld id="{DD486318-9DF8-4AB8-B4FE-404675D97C09}" type="datetimeFigureOut">
               <a:rPr lang="en-US" smtClean="0"/>
-              <a:t>1/28/2022</a:t>
+              <a:t>2/8/2022</a:t>
             </a:fld>
             <a:endParaRPr lang="en-US"/>
           </a:p>
@@ -1736,7 +1736,7 @@
           <a:p>
             <a:fld id="{DD486318-9DF8-4AB8-B4FE-404675D97C09}" type="datetimeFigureOut">
               <a:rPr lang="en-US" smtClean="0"/>
-              <a:t>1/28/2022</a:t>
+              <a:t>2/8/2022</a:t>
             </a:fld>
             <a:endParaRPr lang="en-US"/>
           </a:p>
@@ -1831,7 +1831,7 @@
           <a:p>
             <a:fld id="{DD486318-9DF8-4AB8-B4FE-404675D97C09}" type="datetimeFigureOut">
               <a:rPr lang="en-US" smtClean="0"/>
-              <a:t>1/28/2022</a:t>
+              <a:t>2/8/2022</a:t>
             </a:fld>
             <a:endParaRPr lang="en-US"/>
           </a:p>
@@ -2108,7 +2108,7 @@
           <a:p>
             <a:fld id="{DD486318-9DF8-4AB8-B4FE-404675D97C09}" type="datetimeFigureOut">
               <a:rPr lang="en-US" smtClean="0"/>
-              <a:t>1/28/2022</a:t>
+              <a:t>2/8/2022</a:t>
             </a:fld>
             <a:endParaRPr lang="en-US"/>
           </a:p>
@@ -2365,7 +2365,7 @@
           <a:p>
             <a:fld id="{DD486318-9DF8-4AB8-B4FE-404675D97C09}" type="datetimeFigureOut">
               <a:rPr lang="en-US" smtClean="0"/>
-              <a:t>1/28/2022</a:t>
+              <a:t>2/8/2022</a:t>
             </a:fld>
             <a:endParaRPr lang="en-US"/>
           </a:p>
@@ -2578,7 +2578,7 @@
           <a:p>
             <a:fld id="{DD486318-9DF8-4AB8-B4FE-404675D97C09}" type="datetimeFigureOut">
               <a:rPr lang="en-US" smtClean="0"/>
-              <a:t>1/28/2022</a:t>
+              <a:t>2/8/2022</a:t>
             </a:fld>
             <a:endParaRPr lang="en-US"/>
           </a:p>
@@ -3343,8 +3343,8 @@
         </p:nvSpPr>
         <p:spPr bwMode="auto">
           <a:xfrm>
-            <a:off x="838199" y="1480864"/>
-            <a:ext cx="10515600" cy="4031873"/>
+            <a:off x="838199" y="1234643"/>
+            <a:ext cx="10515600" cy="4524315"/>
           </a:xfrm>
           <a:prstGeom prst="rect">
             <a:avLst/>
@@ -3471,7 +3471,39 @@
                 <a:effectLst/>
                 <a:latin typeface="Georgia" panose="02040502050405020303" pitchFamily="18" charset="0"/>
               </a:rPr>
-              <a:t>Today you’ll be doing an experimental task while we take pictures of your brain as you lay in the MRI machine.</a:t>
+              <a:t>Welcome to th</a:t>
+            </a:r>
+            <a:r>
+              <a:rPr lang="en-US" altLang="en-US" sz="3200" dirty="0" smtClean="0">
+                <a:latin typeface="Georgia" panose="02040502050405020303" pitchFamily="18" charset="0"/>
+              </a:rPr>
+              <a:t>e mock scanner. Here we are going to practice the task </a:t>
+            </a:r>
+            <a:r>
+              <a:rPr kumimoji="0" lang="en-US" altLang="en-US" sz="3200" b="0" i="0" u="none" strike="noStrike" cap="none" normalizeH="0" baseline="0" dirty="0" smtClean="0">
+                <a:ln>
+                  <a:noFill/>
+                </a:ln>
+                <a:solidFill>
+                  <a:schemeClr val="tx1"/>
+                </a:solidFill>
+                <a:effectLst/>
+                <a:latin typeface="Georgia" panose="02040502050405020303" pitchFamily="18" charset="0"/>
+              </a:rPr>
+              <a:t>that you will soon complete 6 repetitions of in the </a:t>
+            </a:r>
+            <a:r>
+              <a:rPr kumimoji="0" lang="en-US" altLang="en-US" sz="3200" b="0" i="0" u="none" strike="noStrike" cap="none" normalizeH="0" baseline="0" dirty="0" smtClean="0">
+                <a:ln>
+                  <a:noFill/>
+                </a:ln>
+                <a:solidFill>
+                  <a:schemeClr val="tx1"/>
+                </a:solidFill>
+                <a:effectLst/>
+                <a:latin typeface="Georgia" panose="02040502050405020303" pitchFamily="18" charset="0"/>
+              </a:rPr>
+              <a:t>MRI machine.</a:t>
             </a:r>
           </a:p>
           <a:p>
@@ -3512,7 +3544,13 @@
               <a:rPr lang="en-US" altLang="en-US" sz="3200" dirty="0" smtClean="0">
                 <a:latin typeface="Georgia" panose="02040502050405020303" pitchFamily="18" charset="0"/>
               </a:rPr>
-              <a:t>You’ll be playing a game called the</a:t>
+              <a:t>Today you’ll </a:t>
+            </a:r>
+            <a:r>
+              <a:rPr lang="en-US" altLang="en-US" sz="3200" dirty="0" smtClean="0">
+                <a:latin typeface="Georgia" panose="02040502050405020303" pitchFamily="18" charset="0"/>
+              </a:rPr>
+              <a:t>be playing a game called the</a:t>
             </a:r>
             <a:br>
               <a:rPr lang="en-US" altLang="en-US" sz="3200" dirty="0" smtClean="0">
@@ -3866,17 +3904,8 @@
               <a:rPr lang="en-US" altLang="en-US" dirty="0" smtClean="0">
                 <a:latin typeface="Georgia" panose="02040502050405020303" pitchFamily="18" charset="0"/>
               </a:rPr>
-              <a:t> the monetary outcomes of the task with </a:t>
-            </a:r>
-            <a:r>
-              <a:rPr lang="en-US" altLang="en-US" dirty="0" smtClean="0">
-                <a:latin typeface="Georgia" panose="02040502050405020303" pitchFamily="18" charset="0"/>
-              </a:rPr>
-              <a:t>them.</a:t>
-            </a:r>
-            <a:endParaRPr lang="en-US" altLang="en-US" dirty="0" smtClean="0">
-              <a:latin typeface="Georgia" panose="02040502050405020303" pitchFamily="18" charset="0"/>
-            </a:endParaRPr>
+              <a:t> the monetary outcomes of the task with them.</a:t>
+            </a:r>
           </a:p>
           <a:p>
             <a:pPr marL="0" lvl="0" indent="0" algn="ctr" eaLnBrk="0" fontAlgn="base" hangingPunct="0">
@@ -4267,13 +4296,7 @@
               <a:rPr lang="en-US" smtClean="0">
                 <a:latin typeface="Georgia" panose="02040502050405020303" pitchFamily="18" charset="0"/>
               </a:rPr>
-              <a:t>recent </a:t>
-            </a:r>
-            <a:r>
-              <a:rPr lang="en-US" smtClean="0">
-                <a:latin typeface="Georgia" panose="02040502050405020303" pitchFamily="18" charset="0"/>
-              </a:rPr>
-              <a:t>participant whose </a:t>
+              <a:t>recent participant whose </a:t>
             </a:r>
             <a:r>
               <a:rPr lang="en-US" dirty="0" smtClean="0">
@@ -4757,7 +4780,19 @@
               <a:rPr lang="en-US" dirty="0" smtClean="0">
                 <a:latin typeface="Georgia" panose="02040502050405020303" pitchFamily="18" charset="0"/>
               </a:rPr>
-              <a:t>If the card had been a ‘4,’ then a guess of ‘lower than 5’ would have been correct. In this case you would see a green arrow pointing up, meaning monetary gain of </a:t>
+              <a:t>If the card had been a ‘4,’ then a guess of ‘lower than 5’ would have been correct. In this case you would see a green arrow pointing up, </a:t>
+            </a:r>
+            <a:r>
+              <a:rPr lang="en-US" dirty="0" smtClean="0">
+                <a:latin typeface="Georgia" panose="02040502050405020303" pitchFamily="18" charset="0"/>
+              </a:rPr>
+              <a:t>meaning a </a:t>
+            </a:r>
+            <a:r>
+              <a:rPr lang="en-US" dirty="0" smtClean="0">
+                <a:latin typeface="Georgia" panose="02040502050405020303" pitchFamily="18" charset="0"/>
+              </a:rPr>
+              <a:t>monetary gain of </a:t>
             </a:r>
             <a:r>
               <a:rPr lang="en-US" dirty="0">
@@ -4775,7 +4810,13 @@
               <a:rPr lang="en-US" dirty="0" smtClean="0">
                 <a:latin typeface="Georgia" panose="02040502050405020303" pitchFamily="18" charset="0"/>
               </a:rPr>
-              <a:t>each for you the partner on the screen</a:t>
+              <a:t>each for both you and the </a:t>
+            </a:r>
+            <a:r>
+              <a:rPr lang="en-US" dirty="0" smtClean="0">
+                <a:latin typeface="Georgia" panose="02040502050405020303" pitchFamily="18" charset="0"/>
+              </a:rPr>
+              <a:t>partner on the screen</a:t>
             </a:r>
             <a:endParaRPr lang="en-US" dirty="0">
               <a:latin typeface="Georgia" panose="02040502050405020303" pitchFamily="18" charset="0"/>

</xml_diff>